<commit_message>
vault backup: 2026-08-11 14:11:02
</commit_message>
<xml_diff>
--- a/_기능 안내판 실행 계획.pptx
+++ b/_기능 안내판 실행 계획.pptx
@@ -2817,7 +2817,7 @@
           </p:nvPr>
         </p:nvGraphicFramePr>
         <p:xfrm>
-          <a:off x="777240" y="2331720"/>
+          <a:off x="777240" y="2286000"/>
           <a:ext cx="10637215" cy="914400"/>
         </p:xfrm>
         <a:graphic>
@@ -2829,7 +2829,7 @@
                 <a:gridCol w="7022592"/>
                 <a:gridCol w="1463040"/>
               </a:tblGrid>
-              <a:tr h="475488">
+              <a:tr h="457200">
                 <a:tc>
                   <a:txBody>
                     <a:bodyPr/>
@@ -3035,7 +3035,7 @@
                   </a:tcPr>
                 </a:tc>
               </a:tr>
-              <a:tr h="475488">
+              <a:tr h="457200">
                 <a:tc>
                   <a:txBody>
                     <a:bodyPr/>
@@ -3241,7 +3241,7 @@
                   </a:tcPr>
                 </a:tc>
               </a:tr>
-              <a:tr h="475488">
+              <a:tr h="457200">
                 <a:tc>
                   <a:txBody>
                     <a:bodyPr/>
@@ -3447,7 +3447,7 @@
                   </a:tcPr>
                 </a:tc>
               </a:tr>
-              <a:tr h="475488">
+              <a:tr h="457200">
                 <a:tc>
                   <a:txBody>
                     <a:bodyPr/>
@@ -3653,7 +3653,7 @@
                   </a:tcPr>
                 </a:tc>
               </a:tr>
-              <a:tr h="475488">
+              <a:tr h="457200">
                 <a:tc>
                   <a:txBody>
                     <a:bodyPr/>
@@ -3859,7 +3859,7 @@
                   </a:tcPr>
                 </a:tc>
               </a:tr>
-              <a:tr h="475488">
+              <a:tr h="457200">
                 <a:tc>
                   <a:txBody>
                     <a:bodyPr/>
@@ -4065,7 +4065,7 @@
                   </a:tcPr>
                 </a:tc>
               </a:tr>
-              <a:tr h="475488">
+              <a:tr h="457200">
                 <a:tc>
                   <a:txBody>
                     <a:bodyPr/>
@@ -4151,7 +4151,7 @@
                           <a:ea typeface="Pretendard" pitchFamily="34" charset="-122"/>
                           <a:cs typeface="Pretendard" pitchFamily="34" charset="-120"/>
                         </a:rPr>
-                        <a:t>작동 확인되면 나머지 저장소 복제 · 고빈도만 얇은 스킬</a:t>
+                        <a:t>나머지 저장소에 복제 · 고빈도만 얇은 스킬로 승격</a:t>
                       </a:r>
                       <a:endParaRPr lang="en-US" sz="1200" dirty="0">
                         <a:latin typeface="Pretendard" charset="0"/>
@@ -4271,10 +4271,269 @@
                   </a:tcPr>
                 </a:tc>
               </a:tr>
+              <a:tr h="457200">
+                <a:tc>
+                  <a:txBody>
+                    <a:bodyPr/>
+                    <a:lstStyle/>
+                    <a:p>
+                      <a:pPr indent="0" marL="0">
+                        <a:buNone/>
+                      </a:pPr>
+                      <a:r>
+                        <a:rPr lang="en-US" sz="1250" dirty="0">
+                          <a:solidFill>
+                            <a:srgbClr val="6C4CFF"/>
+                          </a:solidFill>
+                          <a:latin typeface="Pretendard SemiBold" pitchFamily="34" charset="0"/>
+                          <a:ea typeface="Pretendard SemiBold" pitchFamily="34" charset="-122"/>
+                          <a:cs typeface="Pretendard SemiBold" pitchFamily="34" charset="-120"/>
+                        </a:rPr>
+                        <a:t>7  플러그인 배포</a:t>
+                      </a:r>
+                      <a:endParaRPr lang="en-US" sz="1250" dirty="0">
+                        <a:latin typeface="Pretendard SemiBold" charset="0"/>
+                        <a:ea typeface="Pretendard SemiBold" charset="0"/>
+                        <a:cs typeface="Pretendard SemiBold" charset="0"/>
+                      </a:endParaRPr>
+                    </a:p>
+                  </a:txBody>
+                  <a:tcPr marL="101600" marR="101600" marT="38100" marB="38100" anchor="ctr">
+                    <a:lnL w="6350" cap="flat" cmpd="sng" algn="ctr">
+                      <a:solidFill>
+                        <a:srgbClr val="E5E7EB"/>
+                      </a:solidFill>
+                      <a:prstDash val="solid"/>
+                      <a:round/>
+                      <a:headEnd type="none" w="med" len="med"/>
+                      <a:tailEnd type="none" w="med" len="med"/>
+                    </a:lnL>
+                    <a:lnR w="6350" cap="flat" cmpd="sng" algn="ctr">
+                      <a:solidFill>
+                        <a:srgbClr val="E5E7EB"/>
+                      </a:solidFill>
+                      <a:prstDash val="solid"/>
+                      <a:round/>
+                      <a:headEnd type="none" w="med" len="med"/>
+                      <a:tailEnd type="none" w="med" len="med"/>
+                    </a:lnR>
+                    <a:lnT w="6350" cap="flat" cmpd="sng" algn="ctr">
+                      <a:solidFill>
+                        <a:srgbClr val="E5E7EB"/>
+                      </a:solidFill>
+                      <a:prstDash val="solid"/>
+                      <a:round/>
+                      <a:headEnd type="none" w="med" len="med"/>
+                      <a:tailEnd type="none" w="med" len="med"/>
+                    </a:lnT>
+                    <a:lnB w="6350" cap="flat" cmpd="sng" algn="ctr">
+                      <a:solidFill>
+                        <a:srgbClr val="E5E7EB"/>
+                      </a:solidFill>
+                      <a:prstDash val="solid"/>
+                      <a:round/>
+                      <a:headEnd type="none" w="med" len="med"/>
+                      <a:tailEnd type="none" w="med" len="med"/>
+                    </a:lnB>
+                    <a:solidFill>
+                      <a:srgbClr val="F5F5F7"/>
+                    </a:solidFill>
+                  </a:tcPr>
+                </a:tc>
+                <a:tc>
+                  <a:txBody>
+                    <a:bodyPr/>
+                    <a:lstStyle/>
+                    <a:p>
+                      <a:pPr indent="0" marL="0">
+                        <a:buNone/>
+                      </a:pPr>
+                      <a:r>
+                        <a:rPr lang="en-US" sz="1200" dirty="0">
+                          <a:solidFill>
+                            <a:srgbClr val="55555A"/>
+                          </a:solidFill>
+                          <a:latin typeface="Pretendard" pitchFamily="34" charset="0"/>
+                          <a:ea typeface="Pretendard" pitchFamily="34" charset="-122"/>
+                          <a:cs typeface="Pretendard" pitchFamily="34" charset="-120"/>
+                        </a:rPr>
+                        <a:t>안내판·스킬·도구를 묶어 어느 볼트·맨 바깥에서도 로드 (진단서 D안)</a:t>
+                      </a:r>
+                      <a:endParaRPr lang="en-US" sz="1200" dirty="0">
+                        <a:latin typeface="Pretendard" charset="0"/>
+                        <a:ea typeface="Pretendard" charset="0"/>
+                        <a:cs typeface="Pretendard" charset="0"/>
+                      </a:endParaRPr>
+                    </a:p>
+                  </a:txBody>
+                  <a:tcPr marL="101600" marR="101600" marT="38100" marB="38100" anchor="ctr">
+                    <a:lnL w="6350" cap="flat" cmpd="sng" algn="ctr">
+                      <a:solidFill>
+                        <a:srgbClr val="E5E7EB"/>
+                      </a:solidFill>
+                      <a:prstDash val="solid"/>
+                      <a:round/>
+                      <a:headEnd type="none" w="med" len="med"/>
+                      <a:tailEnd type="none" w="med" len="med"/>
+                    </a:lnL>
+                    <a:lnR w="6350" cap="flat" cmpd="sng" algn="ctr">
+                      <a:solidFill>
+                        <a:srgbClr val="E5E7EB"/>
+                      </a:solidFill>
+                      <a:prstDash val="solid"/>
+                      <a:round/>
+                      <a:headEnd type="none" w="med" len="med"/>
+                      <a:tailEnd type="none" w="med" len="med"/>
+                    </a:lnR>
+                    <a:lnT w="6350" cap="flat" cmpd="sng" algn="ctr">
+                      <a:solidFill>
+                        <a:srgbClr val="E5E7EB"/>
+                      </a:solidFill>
+                      <a:prstDash val="solid"/>
+                      <a:round/>
+                      <a:headEnd type="none" w="med" len="med"/>
+                      <a:tailEnd type="none" w="med" len="med"/>
+                    </a:lnT>
+                    <a:lnB w="6350" cap="flat" cmpd="sng" algn="ctr">
+                      <a:solidFill>
+                        <a:srgbClr val="E5E7EB"/>
+                      </a:solidFill>
+                      <a:prstDash val="solid"/>
+                      <a:round/>
+                      <a:headEnd type="none" w="med" len="med"/>
+                      <a:tailEnd type="none" w="med" len="med"/>
+                    </a:lnB>
+                    <a:solidFill>
+                      <a:srgbClr val="F5F5F7"/>
+                    </a:solidFill>
+                  </a:tcPr>
+                </a:tc>
+                <a:tc>
+                  <a:txBody>
+                    <a:bodyPr/>
+                    <a:lstStyle/>
+                    <a:p>
+                      <a:pPr algn="ctr" indent="0" marL="0">
+                        <a:buNone/>
+                      </a:pPr>
+                      <a:r>
+                        <a:rPr lang="en-US" sz="1200" dirty="0">
+                          <a:solidFill>
+                            <a:srgbClr val="6E6E73"/>
+                          </a:solidFill>
+                          <a:latin typeface="Pretendard Medium" pitchFamily="34" charset="0"/>
+                          <a:ea typeface="Pretendard Medium" pitchFamily="34" charset="-122"/>
+                          <a:cs typeface="Pretendard Medium" pitchFamily="34" charset="-120"/>
+                        </a:rPr>
+                        <a:t>이후</a:t>
+                      </a:r>
+                      <a:endParaRPr lang="en-US" sz="1200" dirty="0">
+                        <a:latin typeface="Pretendard Medium" charset="0"/>
+                        <a:ea typeface="Pretendard Medium" charset="0"/>
+                        <a:cs typeface="Pretendard Medium" charset="0"/>
+                      </a:endParaRPr>
+                    </a:p>
+                  </a:txBody>
+                  <a:tcPr marL="101600" marR="101600" marT="38100" marB="38100" anchor="ctr">
+                    <a:lnL w="6350" cap="flat" cmpd="sng" algn="ctr">
+                      <a:solidFill>
+                        <a:srgbClr val="E5E7EB"/>
+                      </a:solidFill>
+                      <a:prstDash val="solid"/>
+                      <a:round/>
+                      <a:headEnd type="none" w="med" len="med"/>
+                      <a:tailEnd type="none" w="med" len="med"/>
+                    </a:lnL>
+                    <a:lnR w="6350" cap="flat" cmpd="sng" algn="ctr">
+                      <a:solidFill>
+                        <a:srgbClr val="E5E7EB"/>
+                      </a:solidFill>
+                      <a:prstDash val="solid"/>
+                      <a:round/>
+                      <a:headEnd type="none" w="med" len="med"/>
+                      <a:tailEnd type="none" w="med" len="med"/>
+                    </a:lnR>
+                    <a:lnT w="6350" cap="flat" cmpd="sng" algn="ctr">
+                      <a:solidFill>
+                        <a:srgbClr val="E5E7EB"/>
+                      </a:solidFill>
+                      <a:prstDash val="solid"/>
+                      <a:round/>
+                      <a:headEnd type="none" w="med" len="med"/>
+                      <a:tailEnd type="none" w="med" len="med"/>
+                    </a:lnT>
+                    <a:lnB w="6350" cap="flat" cmpd="sng" algn="ctr">
+                      <a:solidFill>
+                        <a:srgbClr val="E5E7EB"/>
+                      </a:solidFill>
+                      <a:prstDash val="solid"/>
+                      <a:round/>
+                      <a:headEnd type="none" w="med" len="med"/>
+                      <a:tailEnd type="none" w="med" len="med"/>
+                    </a:lnB>
+                    <a:solidFill>
+                      <a:srgbClr val="F5F5F7"/>
+                    </a:solidFill>
+                  </a:tcPr>
+                </a:tc>
+              </a:tr>
             </a:tbl>
           </a:graphicData>
         </a:graphic>
       </p:graphicFrame>
+      <p:sp>
+        <p:nvSpPr>
+          <p:cNvPr id="9" name="Text 6"/>
+          <p:cNvSpPr/>
+          <p:nvPr/>
+        </p:nvSpPr>
+        <p:spPr>
+          <a:xfrm>
+            <a:off x="777240" y="5852160"/>
+            <a:ext cx="10637215" cy="365760"/>
+          </a:xfrm>
+          <a:prstGeom prst="rect">
+            <a:avLst/>
+          </a:prstGeom>
+          <a:noFill/>
+          <a:ln/>
+        </p:spPr>
+        <p:txBody>
+          <a:bodyPr wrap="square" lIns="0" tIns="0" rIns="0" bIns="0" rtlCol="0" anchor="ctr"/>
+          <a:lstStyle/>
+          <a:p>
+            <a:pPr indent="0" marL="0">
+              <a:buNone/>
+            </a:pPr>
+            <a:r>
+              <a:rPr lang="en-US" sz="1200" dirty="0">
+                <a:solidFill>
+                  <a:srgbClr val="6C4CFF"/>
+                </a:solidFill>
+                <a:latin typeface="Pretendard SemiBold" pitchFamily="34" charset="0"/>
+                <a:ea typeface="Pretendard SemiBold" pitchFamily="34" charset="-122"/>
+                <a:cs typeface="Pretendard SemiBold" pitchFamily="34" charset="-120"/>
+              </a:rPr>
+              <a:t>6~7단계 = ‘아무 볼트에서나’ 되게 하는 확장.  </a:t>
+            </a:r>
+            <a:pPr indent="0" marL="0">
+              <a:buNone/>
+            </a:pPr>
+            <a:r>
+              <a:rPr lang="en-US" sz="1200" dirty="0">
+                <a:solidFill>
+                  <a:srgbClr val="55555A"/>
+                </a:solidFill>
+                <a:latin typeface="Pretendard" pitchFamily="34" charset="0"/>
+                <a:ea typeface="Pretendard" pitchFamily="34" charset="-122"/>
+                <a:cs typeface="Pretendard" pitchFamily="34" charset="-120"/>
+              </a:rPr>
+              <a:t>1곳이 작동 확인되면 복제하고, 마지막에 플러그인으로 어디서 켜도 로드되게 만든다.</a:t>
+            </a:r>
+            <a:endParaRPr lang="en-US" sz="1200" dirty="0"/>
+          </a:p>
+        </p:txBody>
+      </p:sp>
     </p:spTree>
   </p:cSld>
   <p:clrMapOvr>
@@ -16201,7 +16460,7 @@
                 <a:ea typeface="Pretendard" pitchFamily="34" charset="-122"/>
                 <a:cs typeface="Pretendard" pitchFamily="34" charset="-120"/>
               </a:rPr>
-              <a:t>각 저장소 안내판은 그 볼트에서 작동. 어느 볼트·맨 바깥에서 켜도 되게 하려면 → 플러그인 배포(진단서 D안, 이후 단계).</a:t>
+              <a:t>각 저장소 안내판은 그 볼트에서 작동. 어느 볼트·맨 바깥에서 켜도 되게 하려면 → 플러그인 배포(진단서 D안) = 실행 순서 7단계.</a:t>
             </a:r>
             <a:endParaRPr lang="en-US" sz="1250" dirty="0"/>
           </a:p>

</xml_diff>